<commit_message>
review 2 ppt uloaded
</commit_message>
<xml_diff>
--- a/Idea/REVIEW 2.pptx
+++ b/Idea/REVIEW 2.pptx
@@ -153,7 +153,7 @@
       </p:grpSpPr>
       <p:sp>
         <p:nvSpPr>
-          <p:cNvPr id="423529678" name="Header Placeholder 1"/>
+          <p:cNvPr id="385514699" name="Header Placeholder 1"/>
           <p:cNvSpPr>
             <a:spLocks noGrp="1"/>
           </p:cNvSpPr>
@@ -187,7 +187,7 @@
       </p:sp>
       <p:sp>
         <p:nvSpPr>
-          <p:cNvPr id="1520139562" name="Date Placeholder 2"/>
+          <p:cNvPr id="334987355" name="Date Placeholder 2"/>
           <p:cNvSpPr>
             <a:spLocks noGrp="1"/>
           </p:cNvSpPr>
@@ -225,7 +225,7 @@
       </p:sp>
       <p:sp>
         <p:nvSpPr>
-          <p:cNvPr id="181419721" name="Slide Image Placeholder 3"/>
+          <p:cNvPr id="1519145735" name="Slide Image Placeholder 3"/>
           <p:cNvSpPr>
             <a:spLocks noChangeAspect="1" noGrp="1" noRot="1"/>
           </p:cNvSpPr>
@@ -261,7 +261,7 @@
       </p:sp>
       <p:sp>
         <p:nvSpPr>
-          <p:cNvPr id="462014405" name="Notes Placeholder 4"/>
+          <p:cNvPr id="1486556170" name="Notes Placeholder 4"/>
           <p:cNvSpPr>
             <a:spLocks noGrp="1"/>
           </p:cNvSpPr>
@@ -335,7 +335,7 @@
       </p:sp>
       <p:sp>
         <p:nvSpPr>
-          <p:cNvPr id="327996201" name="Footer Placeholder 5"/>
+          <p:cNvPr id="361278126" name="Footer Placeholder 5"/>
           <p:cNvSpPr>
             <a:spLocks noGrp="1"/>
           </p:cNvSpPr>
@@ -369,7 +369,7 @@
       </p:sp>
       <p:sp>
         <p:nvSpPr>
-          <p:cNvPr id="1751542789" name="Slide Number Placeholder 6"/>
+          <p:cNvPr id="807610770" name="Slide Number Placeholder 6"/>
           <p:cNvSpPr>
             <a:spLocks noGrp="1"/>
           </p:cNvSpPr>
@@ -522,7 +522,7 @@
       </p:grpSpPr>
       <p:sp>
         <p:nvSpPr>
-          <p:cNvPr id="112027773" name="Slide Image Placeholder 1"/>
+          <p:cNvPr id="1083069079" name="Slide Image Placeholder 1"/>
           <p:cNvSpPr>
             <a:spLocks noChangeAspect="1" noGrp="1" noRot="1"/>
           </p:cNvSpPr>
@@ -534,7 +534,7 @@
       </p:sp>
       <p:sp>
         <p:nvSpPr>
-          <p:cNvPr id="1228299017" name="Notes Placeholder 2"/>
+          <p:cNvPr id="785370518" name="Notes Placeholder 2"/>
           <p:cNvSpPr>
             <a:spLocks noGrp="1"/>
           </p:cNvSpPr>
@@ -556,7 +556,7 @@
       </p:sp>
       <p:sp>
         <p:nvSpPr>
-          <p:cNvPr id="694561984" name="Slide Number Placeholder 3"/>
+          <p:cNvPr id="910614927" name="Slide Number Placeholder 3"/>
           <p:cNvSpPr>
             <a:spLocks noGrp="1"/>
           </p:cNvSpPr>
@@ -607,7 +607,7 @@
       </p:grpSpPr>
       <p:sp>
         <p:nvSpPr>
-          <p:cNvPr id="1321650126" name="Slide Image Placeholder 1"/>
+          <p:cNvPr id="852158163" name="Slide Image Placeholder 1"/>
           <p:cNvSpPr>
             <a:spLocks noChangeAspect="1" noGrp="1" noRot="1"/>
           </p:cNvSpPr>
@@ -619,7 +619,7 @@
       </p:sp>
       <p:sp>
         <p:nvSpPr>
-          <p:cNvPr id="203197460" name="Notes Placeholder 2"/>
+          <p:cNvPr id="958664113" name="Notes Placeholder 2"/>
           <p:cNvSpPr>
             <a:spLocks noGrp="1"/>
           </p:cNvSpPr>
@@ -641,7 +641,7 @@
       </p:sp>
       <p:sp>
         <p:nvSpPr>
-          <p:cNvPr id="338390444" name="Slide Number Placeholder 3"/>
+          <p:cNvPr id="33517923" name="Slide Number Placeholder 3"/>
           <p:cNvSpPr>
             <a:spLocks noGrp="1"/>
           </p:cNvSpPr>
@@ -692,7 +692,7 @@
       </p:grpSpPr>
       <p:sp>
         <p:nvSpPr>
-          <p:cNvPr id="1523978729" name="Slide Image Placeholder 1"/>
+          <p:cNvPr id="277545351" name="Slide Image Placeholder 1"/>
           <p:cNvSpPr>
             <a:spLocks noChangeAspect="1" noGrp="1" noRot="1"/>
           </p:cNvSpPr>
@@ -704,7 +704,7 @@
       </p:sp>
       <p:sp>
         <p:nvSpPr>
-          <p:cNvPr id="912351540" name="Notes Placeholder 2"/>
+          <p:cNvPr id="1306341873" name="Notes Placeholder 2"/>
           <p:cNvSpPr>
             <a:spLocks noGrp="1"/>
           </p:cNvSpPr>
@@ -726,7 +726,7 @@
       </p:sp>
       <p:sp>
         <p:nvSpPr>
-          <p:cNvPr id="1932404325" name="Slide Number Placeholder 3"/>
+          <p:cNvPr id="470084816" name="Slide Number Placeholder 3"/>
           <p:cNvSpPr>
             <a:spLocks noGrp="1"/>
           </p:cNvSpPr>
@@ -777,7 +777,7 @@
       </p:grpSpPr>
       <p:sp>
         <p:nvSpPr>
-          <p:cNvPr id="269646559" name="Slide Image Placeholder 1"/>
+          <p:cNvPr id="1284911304" name="Slide Image Placeholder 1"/>
           <p:cNvSpPr>
             <a:spLocks noChangeAspect="1" noGrp="1" noRot="1"/>
           </p:cNvSpPr>
@@ -789,7 +789,7 @@
       </p:sp>
       <p:sp>
         <p:nvSpPr>
-          <p:cNvPr id="1965224387" name="Notes Placeholder 2"/>
+          <p:cNvPr id="1279742657" name="Notes Placeholder 2"/>
           <p:cNvSpPr>
             <a:spLocks noGrp="1"/>
           </p:cNvSpPr>
@@ -811,7 +811,7 @@
       </p:sp>
       <p:sp>
         <p:nvSpPr>
-          <p:cNvPr id="229303182" name="Slide Number Placeholder 3"/>
+          <p:cNvPr id="1891441167" name="Slide Number Placeholder 3"/>
           <p:cNvSpPr>
             <a:spLocks noGrp="1"/>
           </p:cNvSpPr>
@@ -862,7 +862,7 @@
       </p:grpSpPr>
       <p:sp>
         <p:nvSpPr>
-          <p:cNvPr id="1687671149" name="Slide Image Placeholder 1"/>
+          <p:cNvPr id="114933661" name="Slide Image Placeholder 1"/>
           <p:cNvSpPr>
             <a:spLocks noChangeAspect="1" noGrp="1" noRot="1"/>
           </p:cNvSpPr>
@@ -874,7 +874,7 @@
       </p:sp>
       <p:sp>
         <p:nvSpPr>
-          <p:cNvPr id="418928950" name="Notes Placeholder 2"/>
+          <p:cNvPr id="1204839001" name="Notes Placeholder 2"/>
           <p:cNvSpPr>
             <a:spLocks noGrp="1"/>
           </p:cNvSpPr>
@@ -896,7 +896,7 @@
       </p:sp>
       <p:sp>
         <p:nvSpPr>
-          <p:cNvPr id="474415169" name="Slide Number Placeholder 3"/>
+          <p:cNvPr id="1960831661" name="Slide Number Placeholder 3"/>
           <p:cNvSpPr>
             <a:spLocks noGrp="1"/>
           </p:cNvSpPr>
@@ -947,7 +947,7 @@
       </p:grpSpPr>
       <p:sp>
         <p:nvSpPr>
-          <p:cNvPr id="1271031264" name="Slide Image Placeholder 1"/>
+          <p:cNvPr id="1930986527" name="Slide Image Placeholder 1"/>
           <p:cNvSpPr>
             <a:spLocks noChangeAspect="1" noGrp="1" noRot="1"/>
           </p:cNvSpPr>
@@ -959,7 +959,7 @@
       </p:sp>
       <p:sp>
         <p:nvSpPr>
-          <p:cNvPr id="1430064150" name="Notes Placeholder 2"/>
+          <p:cNvPr id="905747436" name="Notes Placeholder 2"/>
           <p:cNvSpPr>
             <a:spLocks noGrp="1"/>
           </p:cNvSpPr>
@@ -981,7 +981,7 @@
       </p:sp>
       <p:sp>
         <p:nvSpPr>
-          <p:cNvPr id="2093813963" name="Slide Number Placeholder 3"/>
+          <p:cNvPr id="1091166594" name="Slide Number Placeholder 3"/>
           <p:cNvSpPr>
             <a:spLocks noGrp="1"/>
           </p:cNvSpPr>
@@ -1032,7 +1032,7 @@
       </p:grpSpPr>
       <p:sp>
         <p:nvSpPr>
-          <p:cNvPr id="2" name="Slide Image Placeholder 1"/>
+          <p:cNvPr id="238931288" name="Slide Image Placeholder 1"/>
           <p:cNvSpPr>
             <a:spLocks noChangeAspect="1" noGrp="1" noRot="1"/>
           </p:cNvSpPr>
@@ -1044,7 +1044,7 @@
       </p:sp>
       <p:sp>
         <p:nvSpPr>
-          <p:cNvPr id="3" name="Notes Placeholder 2"/>
+          <p:cNvPr id="999939676" name="Notes Placeholder 2"/>
           <p:cNvSpPr>
             <a:spLocks noGrp="1"/>
           </p:cNvSpPr>
@@ -1066,7 +1066,7 @@
       </p:sp>
       <p:sp>
         <p:nvSpPr>
-          <p:cNvPr id="4" name="Slide Number Placeholder 3"/>
+          <p:cNvPr id="19060272" name="Slide Number Placeholder 3"/>
           <p:cNvSpPr>
             <a:spLocks noGrp="1"/>
           </p:cNvSpPr>
@@ -1117,7 +1117,7 @@
       </p:grpSpPr>
       <p:sp>
         <p:nvSpPr>
-          <p:cNvPr id="1832842901" name="Slide Image Placeholder 1"/>
+          <p:cNvPr id="1158129098" name="Slide Image Placeholder 1"/>
           <p:cNvSpPr>
             <a:spLocks noChangeAspect="1" noGrp="1" noRot="1"/>
           </p:cNvSpPr>
@@ -1129,7 +1129,7 @@
       </p:sp>
       <p:sp>
         <p:nvSpPr>
-          <p:cNvPr id="1955205834" name="Notes Placeholder 2"/>
+          <p:cNvPr id="1253706704" name="Notes Placeholder 2"/>
           <p:cNvSpPr>
             <a:spLocks noGrp="1"/>
           </p:cNvSpPr>
@@ -1151,7 +1151,7 @@
       </p:sp>
       <p:sp>
         <p:nvSpPr>
-          <p:cNvPr id="692508005" name="Slide Number Placeholder 3"/>
+          <p:cNvPr id="276590752" name="Slide Number Placeholder 3"/>
           <p:cNvSpPr>
             <a:spLocks noGrp="1"/>
           </p:cNvSpPr>
@@ -1202,7 +1202,7 @@
       </p:grpSpPr>
       <p:sp>
         <p:nvSpPr>
-          <p:cNvPr id="1599747130" name="Slide Image Placeholder 1"/>
+          <p:cNvPr id="2054043388" name="Slide Image Placeholder 1"/>
           <p:cNvSpPr>
             <a:spLocks noChangeAspect="1" noGrp="1" noRot="1"/>
           </p:cNvSpPr>
@@ -1214,7 +1214,7 @@
       </p:sp>
       <p:sp>
         <p:nvSpPr>
-          <p:cNvPr id="767999071" name="Notes Placeholder 2"/>
+          <p:cNvPr id="1434032244" name="Notes Placeholder 2"/>
           <p:cNvSpPr>
             <a:spLocks noGrp="1"/>
           </p:cNvSpPr>
@@ -1236,7 +1236,7 @@
       </p:sp>
       <p:sp>
         <p:nvSpPr>
-          <p:cNvPr id="1770976368" name="Slide Number Placeholder 3"/>
+          <p:cNvPr id="1731941273" name="Slide Number Placeholder 3"/>
           <p:cNvSpPr>
             <a:spLocks noGrp="1"/>
           </p:cNvSpPr>
@@ -1287,7 +1287,7 @@
       </p:grpSpPr>
       <p:sp>
         <p:nvSpPr>
-          <p:cNvPr id="721866209" name="Slide Image Placeholder 1"/>
+          <p:cNvPr id="831685894" name="Slide Image Placeholder 1"/>
           <p:cNvSpPr>
             <a:spLocks noChangeAspect="1" noGrp="1" noRot="1"/>
           </p:cNvSpPr>
@@ -1299,7 +1299,7 @@
       </p:sp>
       <p:sp>
         <p:nvSpPr>
-          <p:cNvPr id="1785031157" name="Notes Placeholder 2"/>
+          <p:cNvPr id="951156079" name="Notes Placeholder 2"/>
           <p:cNvSpPr>
             <a:spLocks noGrp="1"/>
           </p:cNvSpPr>
@@ -1321,7 +1321,7 @@
       </p:sp>
       <p:sp>
         <p:nvSpPr>
-          <p:cNvPr id="144813100" name="Slide Number Placeholder 3"/>
+          <p:cNvPr id="308647062" name="Slide Number Placeholder 3"/>
           <p:cNvSpPr>
             <a:spLocks noGrp="1"/>
           </p:cNvSpPr>
@@ -1372,7 +1372,7 @@
       </p:grpSpPr>
       <p:sp>
         <p:nvSpPr>
-          <p:cNvPr id="1706126347" name="Slide Image Placeholder 1"/>
+          <p:cNvPr id="298306124" name="Slide Image Placeholder 1"/>
           <p:cNvSpPr>
             <a:spLocks noChangeAspect="1" noGrp="1" noRot="1"/>
           </p:cNvSpPr>
@@ -1384,7 +1384,7 @@
       </p:sp>
       <p:sp>
         <p:nvSpPr>
-          <p:cNvPr id="396541444" name="Notes Placeholder 2"/>
+          <p:cNvPr id="1186565648" name="Notes Placeholder 2"/>
           <p:cNvSpPr>
             <a:spLocks noGrp="1"/>
           </p:cNvSpPr>
@@ -1406,7 +1406,7 @@
       </p:sp>
       <p:sp>
         <p:nvSpPr>
-          <p:cNvPr id="1879329520" name="Slide Number Placeholder 3"/>
+          <p:cNvPr id="471158175" name="Slide Number Placeholder 3"/>
           <p:cNvSpPr>
             <a:spLocks noGrp="1"/>
           </p:cNvSpPr>
@@ -1457,7 +1457,7 @@
       </p:grpSpPr>
       <p:sp>
         <p:nvSpPr>
-          <p:cNvPr id="423895846" name="Slide Image Placeholder 1"/>
+          <p:cNvPr id="115106975" name="Slide Image Placeholder 1"/>
           <p:cNvSpPr>
             <a:spLocks noChangeAspect="1" noGrp="1" noRot="1"/>
           </p:cNvSpPr>
@@ -1469,7 +1469,7 @@
       </p:sp>
       <p:sp>
         <p:nvSpPr>
-          <p:cNvPr id="1782461315" name="Notes Placeholder 2"/>
+          <p:cNvPr id="1131227453" name="Notes Placeholder 2"/>
           <p:cNvSpPr>
             <a:spLocks noGrp="1"/>
           </p:cNvSpPr>
@@ -1491,7 +1491,7 @@
       </p:sp>
       <p:sp>
         <p:nvSpPr>
-          <p:cNvPr id="1602054526" name="Slide Number Placeholder 3"/>
+          <p:cNvPr id="140271243" name="Slide Number Placeholder 3"/>
           <p:cNvSpPr>
             <a:spLocks noGrp="1"/>
           </p:cNvSpPr>
@@ -1542,7 +1542,7 @@
       </p:grpSpPr>
       <p:sp>
         <p:nvSpPr>
-          <p:cNvPr id="2117602581" name="Slide Image Placeholder 1"/>
+          <p:cNvPr id="1756774276" name="Slide Image Placeholder 1"/>
           <p:cNvSpPr>
             <a:spLocks noChangeAspect="1" noGrp="1" noRot="1"/>
           </p:cNvSpPr>
@@ -1554,7 +1554,7 @@
       </p:sp>
       <p:sp>
         <p:nvSpPr>
-          <p:cNvPr id="598466984" name="Notes Placeholder 2"/>
+          <p:cNvPr id="888295806" name="Notes Placeholder 2"/>
           <p:cNvSpPr>
             <a:spLocks noGrp="1"/>
           </p:cNvSpPr>
@@ -1576,7 +1576,7 @@
       </p:sp>
       <p:sp>
         <p:nvSpPr>
-          <p:cNvPr id="1509173577" name="Slide Number Placeholder 3"/>
+          <p:cNvPr id="1011711948" name="Slide Number Placeholder 3"/>
           <p:cNvSpPr>
             <a:spLocks noGrp="1"/>
           </p:cNvSpPr>
@@ -1627,7 +1627,7 @@
       </p:grpSpPr>
       <p:sp>
         <p:nvSpPr>
-          <p:cNvPr id="1613983879" name="Slide Image Placeholder 1"/>
+          <p:cNvPr id="1222187407" name="Slide Image Placeholder 1"/>
           <p:cNvSpPr>
             <a:spLocks noChangeAspect="1" noGrp="1" noRot="1"/>
           </p:cNvSpPr>
@@ -1639,7 +1639,7 @@
       </p:sp>
       <p:sp>
         <p:nvSpPr>
-          <p:cNvPr id="564191096" name="Notes Placeholder 2"/>
+          <p:cNvPr id="600511557" name="Notes Placeholder 2"/>
           <p:cNvSpPr>
             <a:spLocks noGrp="1"/>
           </p:cNvSpPr>
@@ -1661,7 +1661,7 @@
       </p:sp>
       <p:sp>
         <p:nvSpPr>
-          <p:cNvPr id="1960173753" name="Slide Number Placeholder 3"/>
+          <p:cNvPr id="2028534978" name="Slide Number Placeholder 3"/>
           <p:cNvSpPr>
             <a:spLocks noGrp="1"/>
           </p:cNvSpPr>
@@ -1712,7 +1712,7 @@
       </p:grpSpPr>
       <p:sp>
         <p:nvSpPr>
-          <p:cNvPr id="1100532427" name="Slide Image Placeholder 1"/>
+          <p:cNvPr id="200716953" name="Slide Image Placeholder 1"/>
           <p:cNvSpPr>
             <a:spLocks noChangeAspect="1" noGrp="1" noRot="1"/>
           </p:cNvSpPr>
@@ -1724,7 +1724,7 @@
       </p:sp>
       <p:sp>
         <p:nvSpPr>
-          <p:cNvPr id="1790292604" name="Notes Placeholder 2"/>
+          <p:cNvPr id="1328359908" name="Notes Placeholder 2"/>
           <p:cNvSpPr>
             <a:spLocks noGrp="1"/>
           </p:cNvSpPr>
@@ -1746,7 +1746,7 @@
       </p:sp>
       <p:sp>
         <p:nvSpPr>
-          <p:cNvPr id="1495161427" name="Slide Number Placeholder 3"/>
+          <p:cNvPr id="1708061964" name="Slide Number Placeholder 3"/>
           <p:cNvSpPr>
             <a:spLocks noGrp="1"/>
           </p:cNvSpPr>
@@ -1797,7 +1797,7 @@
       </p:grpSpPr>
       <p:sp>
         <p:nvSpPr>
-          <p:cNvPr id="1685203611" name="Slide Image Placeholder 1"/>
+          <p:cNvPr id="1513736863" name="Slide Image Placeholder 1"/>
           <p:cNvSpPr>
             <a:spLocks noChangeAspect="1" noGrp="1" noRot="1"/>
           </p:cNvSpPr>
@@ -1809,7 +1809,7 @@
       </p:sp>
       <p:sp>
         <p:nvSpPr>
-          <p:cNvPr id="573520062" name="Notes Placeholder 2"/>
+          <p:cNvPr id="843077548" name="Notes Placeholder 2"/>
           <p:cNvSpPr>
             <a:spLocks noGrp="1"/>
           </p:cNvSpPr>
@@ -1831,7 +1831,7 @@
       </p:sp>
       <p:sp>
         <p:nvSpPr>
-          <p:cNvPr id="122171171" name="Slide Number Placeholder 3"/>
+          <p:cNvPr id="1229919926" name="Slide Number Placeholder 3"/>
           <p:cNvSpPr>
             <a:spLocks noGrp="1"/>
           </p:cNvSpPr>
@@ -1882,7 +1882,7 @@
       </p:grpSpPr>
       <p:sp>
         <p:nvSpPr>
-          <p:cNvPr id="2051516738" name="Slide Image Placeholder 1"/>
+          <p:cNvPr id="1767544662" name="Slide Image Placeholder 1"/>
           <p:cNvSpPr>
             <a:spLocks noChangeAspect="1" noGrp="1" noRot="1"/>
           </p:cNvSpPr>
@@ -1894,7 +1894,7 @@
       </p:sp>
       <p:sp>
         <p:nvSpPr>
-          <p:cNvPr id="1163706802" name="Notes Placeholder 2"/>
+          <p:cNvPr id="1217368771" name="Notes Placeholder 2"/>
           <p:cNvSpPr>
             <a:spLocks noGrp="1"/>
           </p:cNvSpPr>
@@ -1916,7 +1916,7 @@
       </p:sp>
       <p:sp>
         <p:nvSpPr>
-          <p:cNvPr id="1228114947" name="Slide Number Placeholder 3"/>
+          <p:cNvPr id="1143949444" name="Slide Number Placeholder 3"/>
           <p:cNvSpPr>
             <a:spLocks noGrp="1"/>
           </p:cNvSpPr>
@@ -1967,7 +1967,7 @@
       </p:grpSpPr>
       <p:sp>
         <p:nvSpPr>
-          <p:cNvPr id="9274585" name="Slide Image Placeholder 1"/>
+          <p:cNvPr id="1681335100" name="Slide Image Placeholder 1"/>
           <p:cNvSpPr>
             <a:spLocks noChangeAspect="1" noGrp="1" noRot="1"/>
           </p:cNvSpPr>
@@ -1979,7 +1979,7 @@
       </p:sp>
       <p:sp>
         <p:nvSpPr>
-          <p:cNvPr id="1449256395" name="Notes Placeholder 2"/>
+          <p:cNvPr id="150727961" name="Notes Placeholder 2"/>
           <p:cNvSpPr>
             <a:spLocks noGrp="1"/>
           </p:cNvSpPr>
@@ -2001,7 +2001,7 @@
       </p:sp>
       <p:sp>
         <p:nvSpPr>
-          <p:cNvPr id="363559790" name="Slide Number Placeholder 3"/>
+          <p:cNvPr id="766794430" name="Slide Number Placeholder 3"/>
           <p:cNvSpPr>
             <a:spLocks noGrp="1"/>
           </p:cNvSpPr>
@@ -2052,7 +2052,7 @@
       </p:grpSpPr>
       <p:sp>
         <p:nvSpPr>
-          <p:cNvPr id="54452121" name="Slide Image Placeholder 1"/>
+          <p:cNvPr id="164551657" name="Slide Image Placeholder 1"/>
           <p:cNvSpPr>
             <a:spLocks noChangeAspect="1" noGrp="1" noRot="1"/>
           </p:cNvSpPr>
@@ -2064,7 +2064,7 @@
       </p:sp>
       <p:sp>
         <p:nvSpPr>
-          <p:cNvPr id="1644761202" name="Notes Placeholder 2"/>
+          <p:cNvPr id="1565523707" name="Notes Placeholder 2"/>
           <p:cNvSpPr>
             <a:spLocks noGrp="1"/>
           </p:cNvSpPr>
@@ -2086,7 +2086,7 @@
       </p:sp>
       <p:sp>
         <p:nvSpPr>
-          <p:cNvPr id="1769168008" name="Slide Number Placeholder 3"/>
+          <p:cNvPr id="2124885440" name="Slide Number Placeholder 3"/>
           <p:cNvSpPr>
             <a:spLocks noGrp="1"/>
           </p:cNvSpPr>
@@ -2137,7 +2137,7 @@
       </p:grpSpPr>
       <p:sp>
         <p:nvSpPr>
-          <p:cNvPr id="341170896" name="Slide Image Placeholder 1"/>
+          <p:cNvPr id="1041000625" name="Slide Image Placeholder 1"/>
           <p:cNvSpPr>
             <a:spLocks noChangeAspect="1" noGrp="1" noRot="1"/>
           </p:cNvSpPr>
@@ -2149,7 +2149,7 @@
       </p:sp>
       <p:sp>
         <p:nvSpPr>
-          <p:cNvPr id="390162349" name="Notes Placeholder 2"/>
+          <p:cNvPr id="205919135" name="Notes Placeholder 2"/>
           <p:cNvSpPr>
             <a:spLocks noGrp="1"/>
           </p:cNvSpPr>
@@ -2171,7 +2171,7 @@
       </p:sp>
       <p:sp>
         <p:nvSpPr>
-          <p:cNvPr id="1211070201" name="Slide Number Placeholder 3"/>
+          <p:cNvPr id="1934911614" name="Slide Number Placeholder 3"/>
           <p:cNvSpPr>
             <a:spLocks noGrp="1"/>
           </p:cNvSpPr>
@@ -2222,7 +2222,7 @@
       </p:grpSpPr>
       <p:sp>
         <p:nvSpPr>
-          <p:cNvPr id="927589063" name="Title 1"/>
+          <p:cNvPr id="627070826" name="Title 1"/>
           <p:cNvSpPr>
             <a:spLocks noGrp="1"/>
           </p:cNvSpPr>
@@ -2253,7 +2253,7 @@
       </p:sp>
       <p:sp>
         <p:nvSpPr>
-          <p:cNvPr id="1977820353" name="Subtitle 2"/>
+          <p:cNvPr id="1359539412" name="Subtitle 2"/>
           <p:cNvSpPr>
             <a:spLocks noGrp="1"/>
           </p:cNvSpPr>
@@ -2375,7 +2375,7 @@
       </p:sp>
       <p:sp>
         <p:nvSpPr>
-          <p:cNvPr id="1240604221" name="Date Placeholder 3"/>
+          <p:cNvPr id="310067285" name="Date Placeholder 3"/>
           <p:cNvSpPr>
             <a:spLocks noGrp="1"/>
           </p:cNvSpPr>
@@ -2401,7 +2401,7 @@
       </p:sp>
       <p:sp>
         <p:nvSpPr>
-          <p:cNvPr id="124419960" name="Footer Placeholder 4"/>
+          <p:cNvPr id="498129509" name="Footer Placeholder 4"/>
           <p:cNvSpPr>
             <a:spLocks noGrp="1"/>
           </p:cNvSpPr>
@@ -2423,7 +2423,7 @@
       </p:sp>
       <p:sp>
         <p:nvSpPr>
-          <p:cNvPr id="1458129412" name="Slide Number Placeholder 5"/>
+          <p:cNvPr id="1641017710" name="Slide Number Placeholder 5"/>
           <p:cNvSpPr>
             <a:spLocks noGrp="1"/>
           </p:cNvSpPr>
@@ -2474,7 +2474,7 @@
       </p:grpSpPr>
       <p:sp>
         <p:nvSpPr>
-          <p:cNvPr id="2026793988" name="Title 1"/>
+          <p:cNvPr id="1158259753" name="Title 1"/>
           <p:cNvSpPr>
             <a:spLocks noGrp="1"/>
           </p:cNvSpPr>
@@ -2500,7 +2500,7 @@
       </p:sp>
       <p:sp>
         <p:nvSpPr>
-          <p:cNvPr id="1216447863" name="Vertical Text Placeholder 2"/>
+          <p:cNvPr id="531289080" name="Vertical Text Placeholder 2"/>
           <p:cNvSpPr>
             <a:spLocks noGrp="1"/>
           </p:cNvSpPr>
@@ -2566,7 +2566,7 @@
       </p:sp>
       <p:sp>
         <p:nvSpPr>
-          <p:cNvPr id="498562053" name="Date Placeholder 3"/>
+          <p:cNvPr id="1754094102" name="Date Placeholder 3"/>
           <p:cNvSpPr>
             <a:spLocks noGrp="1"/>
           </p:cNvSpPr>
@@ -2592,7 +2592,7 @@
       </p:sp>
       <p:sp>
         <p:nvSpPr>
-          <p:cNvPr id="2073568938" name="Footer Placeholder 4"/>
+          <p:cNvPr id="1696199121" name="Footer Placeholder 4"/>
           <p:cNvSpPr>
             <a:spLocks noGrp="1"/>
           </p:cNvSpPr>
@@ -2614,7 +2614,7 @@
       </p:sp>
       <p:sp>
         <p:nvSpPr>
-          <p:cNvPr id="1514557054" name="Slide Number Placeholder 5"/>
+          <p:cNvPr id="18127683" name="Slide Number Placeholder 5"/>
           <p:cNvSpPr>
             <a:spLocks noGrp="1"/>
           </p:cNvSpPr>
@@ -2665,7 +2665,7 @@
       </p:grpSpPr>
       <p:sp>
         <p:nvSpPr>
-          <p:cNvPr id="813808924" name="Vertical Title 1"/>
+          <p:cNvPr id="797434192" name="Vertical Title 1"/>
           <p:cNvSpPr>
             <a:spLocks noGrp="1"/>
           </p:cNvSpPr>
@@ -2696,7 +2696,7 @@
       </p:sp>
       <p:sp>
         <p:nvSpPr>
-          <p:cNvPr id="1312054857" name="Vertical Text Placeholder 2"/>
+          <p:cNvPr id="372295702" name="Vertical Text Placeholder 2"/>
           <p:cNvSpPr>
             <a:spLocks noGrp="1"/>
           </p:cNvSpPr>
@@ -2767,7 +2767,7 @@
       </p:sp>
       <p:sp>
         <p:nvSpPr>
-          <p:cNvPr id="466922693" name="Date Placeholder 3"/>
+          <p:cNvPr id="587232247" name="Date Placeholder 3"/>
           <p:cNvSpPr>
             <a:spLocks noGrp="1"/>
           </p:cNvSpPr>
@@ -2793,7 +2793,7 @@
       </p:sp>
       <p:sp>
         <p:nvSpPr>
-          <p:cNvPr id="1791735138" name="Footer Placeholder 4"/>
+          <p:cNvPr id="897567717" name="Footer Placeholder 4"/>
           <p:cNvSpPr>
             <a:spLocks noGrp="1"/>
           </p:cNvSpPr>
@@ -2815,7 +2815,7 @@
       </p:sp>
       <p:sp>
         <p:nvSpPr>
-          <p:cNvPr id="2126595337" name="Slide Number Placeholder 5"/>
+          <p:cNvPr id="2121163217" name="Slide Number Placeholder 5"/>
           <p:cNvSpPr>
             <a:spLocks noGrp="1"/>
           </p:cNvSpPr>
@@ -2866,7 +2866,7 @@
       </p:grpSpPr>
       <p:sp>
         <p:nvSpPr>
-          <p:cNvPr id="932324300" name="Title 1"/>
+          <p:cNvPr id="1921326905" name="Title 1"/>
           <p:cNvSpPr>
             <a:spLocks noGrp="1"/>
           </p:cNvSpPr>
@@ -2892,7 +2892,7 @@
       </p:sp>
       <p:sp>
         <p:nvSpPr>
-          <p:cNvPr id="614145183" name="Content Placeholder 2"/>
+          <p:cNvPr id="691503972" name="Content Placeholder 2"/>
           <p:cNvSpPr>
             <a:spLocks noGrp="1"/>
           </p:cNvSpPr>
@@ -2958,7 +2958,7 @@
       </p:sp>
       <p:sp>
         <p:nvSpPr>
-          <p:cNvPr id="1528801510" name="Date Placeholder 3"/>
+          <p:cNvPr id="1456496634" name="Date Placeholder 3"/>
           <p:cNvSpPr>
             <a:spLocks noGrp="1"/>
           </p:cNvSpPr>
@@ -2984,7 +2984,7 @@
       </p:sp>
       <p:sp>
         <p:nvSpPr>
-          <p:cNvPr id="6045754" name="Footer Placeholder 4"/>
+          <p:cNvPr id="246601635" name="Footer Placeholder 4"/>
           <p:cNvSpPr>
             <a:spLocks noGrp="1"/>
           </p:cNvSpPr>
@@ -3006,7 +3006,7 @@
       </p:sp>
       <p:sp>
         <p:nvSpPr>
-          <p:cNvPr id="171054984" name="Slide Number Placeholder 5"/>
+          <p:cNvPr id="1237191139" name="Slide Number Placeholder 5"/>
           <p:cNvSpPr>
             <a:spLocks noGrp="1"/>
           </p:cNvSpPr>
@@ -3057,7 +3057,7 @@
       </p:grpSpPr>
       <p:sp>
         <p:nvSpPr>
-          <p:cNvPr id="754045803" name="Title 1"/>
+          <p:cNvPr id="734522481" name="Title 1"/>
           <p:cNvSpPr>
             <a:spLocks noGrp="1"/>
           </p:cNvSpPr>
@@ -3092,7 +3092,7 @@
       </p:sp>
       <p:sp>
         <p:nvSpPr>
-          <p:cNvPr id="760881238" name="Text Placeholder 2"/>
+          <p:cNvPr id="1118111296" name="Text Placeholder 2"/>
           <p:cNvSpPr>
             <a:spLocks noGrp="1"/>
           </p:cNvSpPr>
@@ -3214,7 +3214,7 @@
       </p:sp>
       <p:sp>
         <p:nvSpPr>
-          <p:cNvPr id="548667627" name="Date Placeholder 3"/>
+          <p:cNvPr id="1790251021" name="Date Placeholder 3"/>
           <p:cNvSpPr>
             <a:spLocks noGrp="1"/>
           </p:cNvSpPr>
@@ -3240,7 +3240,7 @@
       </p:sp>
       <p:sp>
         <p:nvSpPr>
-          <p:cNvPr id="776461920" name="Footer Placeholder 4"/>
+          <p:cNvPr id="1085438548" name="Footer Placeholder 4"/>
           <p:cNvSpPr>
             <a:spLocks noGrp="1"/>
           </p:cNvSpPr>
@@ -3262,7 +3262,7 @@
       </p:sp>
       <p:sp>
         <p:nvSpPr>
-          <p:cNvPr id="281794247" name="Slide Number Placeholder 5"/>
+          <p:cNvPr id="1154366899" name="Slide Number Placeholder 5"/>
           <p:cNvSpPr>
             <a:spLocks noGrp="1"/>
           </p:cNvSpPr>
@@ -3313,7 +3313,7 @@
       </p:grpSpPr>
       <p:sp>
         <p:nvSpPr>
-          <p:cNvPr id="1576695104" name="Title 1"/>
+          <p:cNvPr id="228034852" name="Title 1"/>
           <p:cNvSpPr>
             <a:spLocks noGrp="1"/>
           </p:cNvSpPr>
@@ -3339,7 +3339,7 @@
       </p:sp>
       <p:sp>
         <p:nvSpPr>
-          <p:cNvPr id="696873027" name="Content Placeholder 2"/>
+          <p:cNvPr id="708360585" name="Content Placeholder 2"/>
           <p:cNvSpPr>
             <a:spLocks noGrp="1"/>
           </p:cNvSpPr>
@@ -3438,7 +3438,7 @@
       </p:sp>
       <p:sp>
         <p:nvSpPr>
-          <p:cNvPr id="1720913288" name="Content Placeholder 3"/>
+          <p:cNvPr id="473653112" name="Content Placeholder 3"/>
           <p:cNvSpPr>
             <a:spLocks noGrp="1"/>
           </p:cNvSpPr>
@@ -3537,7 +3537,7 @@
       </p:sp>
       <p:sp>
         <p:nvSpPr>
-          <p:cNvPr id="745625270" name="Date Placeholder 4"/>
+          <p:cNvPr id="1312069219" name="Date Placeholder 4"/>
           <p:cNvSpPr>
             <a:spLocks noGrp="1"/>
           </p:cNvSpPr>
@@ -3563,7 +3563,7 @@
       </p:sp>
       <p:sp>
         <p:nvSpPr>
-          <p:cNvPr id="532626849" name="Footer Placeholder 5"/>
+          <p:cNvPr id="1446193726" name="Footer Placeholder 5"/>
           <p:cNvSpPr>
             <a:spLocks noGrp="1"/>
           </p:cNvSpPr>
@@ -3585,7 +3585,7 @@
       </p:sp>
       <p:sp>
         <p:nvSpPr>
-          <p:cNvPr id="688278350" name="Slide Number Placeholder 6"/>
+          <p:cNvPr id="1201054141" name="Slide Number Placeholder 6"/>
           <p:cNvSpPr>
             <a:spLocks noGrp="1"/>
           </p:cNvSpPr>
@@ -3636,7 +3636,7 @@
       </p:grpSpPr>
       <p:sp>
         <p:nvSpPr>
-          <p:cNvPr id="1873406063" name="Title 1"/>
+          <p:cNvPr id="1063973718" name="Title 1"/>
           <p:cNvSpPr>
             <a:spLocks noGrp="1"/>
           </p:cNvSpPr>
@@ -3666,7 +3666,7 @@
       </p:sp>
       <p:sp>
         <p:nvSpPr>
-          <p:cNvPr id="237492393" name="Text Placeholder 2"/>
+          <p:cNvPr id="1114275253" name="Text Placeholder 2"/>
           <p:cNvSpPr>
             <a:spLocks noGrp="1"/>
           </p:cNvSpPr>
@@ -3734,7 +3734,7 @@
       </p:sp>
       <p:sp>
         <p:nvSpPr>
-          <p:cNvPr id="1670443920" name="Content Placeholder 3"/>
+          <p:cNvPr id="361939610" name="Content Placeholder 3"/>
           <p:cNvSpPr>
             <a:spLocks noGrp="1"/>
           </p:cNvSpPr>
@@ -3833,7 +3833,7 @@
       </p:sp>
       <p:sp>
         <p:nvSpPr>
-          <p:cNvPr id="582248062" name="Text Placeholder 4"/>
+          <p:cNvPr id="1872435478" name="Text Placeholder 4"/>
           <p:cNvSpPr>
             <a:spLocks noGrp="1"/>
           </p:cNvSpPr>
@@ -3901,7 +3901,7 @@
       </p:sp>
       <p:sp>
         <p:nvSpPr>
-          <p:cNvPr id="1754582522" name="Content Placeholder 5"/>
+          <p:cNvPr id="1099140675" name="Content Placeholder 5"/>
           <p:cNvSpPr>
             <a:spLocks noGrp="1"/>
           </p:cNvSpPr>
@@ -4000,7 +4000,7 @@
       </p:sp>
       <p:sp>
         <p:nvSpPr>
-          <p:cNvPr id="1315751402" name="Date Placeholder 6"/>
+          <p:cNvPr id="1230485479" name="Date Placeholder 6"/>
           <p:cNvSpPr>
             <a:spLocks noGrp="1"/>
           </p:cNvSpPr>
@@ -4026,7 +4026,7 @@
       </p:sp>
       <p:sp>
         <p:nvSpPr>
-          <p:cNvPr id="1683653469" name="Footer Placeholder 7"/>
+          <p:cNvPr id="1905872935" name="Footer Placeholder 7"/>
           <p:cNvSpPr>
             <a:spLocks noGrp="1"/>
           </p:cNvSpPr>
@@ -4048,7 +4048,7 @@
       </p:sp>
       <p:sp>
         <p:nvSpPr>
-          <p:cNvPr id="1746999130" name="Slide Number Placeholder 8"/>
+          <p:cNvPr id="291687716" name="Slide Number Placeholder 8"/>
           <p:cNvSpPr>
             <a:spLocks noGrp="1"/>
           </p:cNvSpPr>
@@ -4099,7 +4099,7 @@
       </p:grpSpPr>
       <p:sp>
         <p:nvSpPr>
-          <p:cNvPr id="2143638" name="Title 1"/>
+          <p:cNvPr id="1949734535" name="Title 1"/>
           <p:cNvSpPr>
             <a:spLocks noGrp="1"/>
           </p:cNvSpPr>
@@ -4125,7 +4125,7 @@
       </p:sp>
       <p:sp>
         <p:nvSpPr>
-          <p:cNvPr id="8540961" name="Date Placeholder 2"/>
+          <p:cNvPr id="376827931" name="Date Placeholder 2"/>
           <p:cNvSpPr>
             <a:spLocks noGrp="1"/>
           </p:cNvSpPr>
@@ -4151,7 +4151,7 @@
       </p:sp>
       <p:sp>
         <p:nvSpPr>
-          <p:cNvPr id="738065649" name="Footer Placeholder 3"/>
+          <p:cNvPr id="685547708" name="Footer Placeholder 3"/>
           <p:cNvSpPr>
             <a:spLocks noGrp="1"/>
           </p:cNvSpPr>
@@ -4173,7 +4173,7 @@
       </p:sp>
       <p:sp>
         <p:nvSpPr>
-          <p:cNvPr id="1908195600" name="Slide Number Placeholder 4"/>
+          <p:cNvPr id="2038011317" name="Slide Number Placeholder 4"/>
           <p:cNvSpPr>
             <a:spLocks noGrp="1"/>
           </p:cNvSpPr>
@@ -4224,7 +4224,7 @@
       </p:grpSpPr>
       <p:sp>
         <p:nvSpPr>
-          <p:cNvPr id="94935719" name="Date Placeholder 1"/>
+          <p:cNvPr id="1756089516" name="Date Placeholder 1"/>
           <p:cNvSpPr>
             <a:spLocks noGrp="1"/>
           </p:cNvSpPr>
@@ -4250,7 +4250,7 @@
       </p:sp>
       <p:sp>
         <p:nvSpPr>
-          <p:cNvPr id="2103345286" name="Footer Placeholder 2"/>
+          <p:cNvPr id="1542590157" name="Footer Placeholder 2"/>
           <p:cNvSpPr>
             <a:spLocks noGrp="1"/>
           </p:cNvSpPr>
@@ -4272,7 +4272,7 @@
       </p:sp>
       <p:sp>
         <p:nvSpPr>
-          <p:cNvPr id="308774716" name="Slide Number Placeholder 3"/>
+          <p:cNvPr id="1402646810" name="Slide Number Placeholder 3"/>
           <p:cNvSpPr>
             <a:spLocks noGrp="1"/>
           </p:cNvSpPr>
@@ -4323,7 +4323,7 @@
       </p:grpSpPr>
       <p:sp>
         <p:nvSpPr>
-          <p:cNvPr id="425961157" name="Title 1"/>
+          <p:cNvPr id="855160328" name="Title 1"/>
           <p:cNvSpPr>
             <a:spLocks noGrp="1"/>
           </p:cNvSpPr>
@@ -4358,7 +4358,7 @@
       </p:sp>
       <p:sp>
         <p:nvSpPr>
-          <p:cNvPr id="194645837" name="Content Placeholder 2"/>
+          <p:cNvPr id="646328410" name="Content Placeholder 2"/>
           <p:cNvSpPr>
             <a:spLocks noGrp="1"/>
           </p:cNvSpPr>
@@ -4457,7 +4457,7 @@
       </p:sp>
       <p:sp>
         <p:nvSpPr>
-          <p:cNvPr id="2054834296" name="Text Placeholder 3"/>
+          <p:cNvPr id="1094117863" name="Text Placeholder 3"/>
           <p:cNvSpPr>
             <a:spLocks noGrp="1"/>
           </p:cNvSpPr>
@@ -4525,7 +4525,7 @@
       </p:sp>
       <p:sp>
         <p:nvSpPr>
-          <p:cNvPr id="1622336441" name="Date Placeholder 4"/>
+          <p:cNvPr id="1095898718" name="Date Placeholder 4"/>
           <p:cNvSpPr>
             <a:spLocks noGrp="1"/>
           </p:cNvSpPr>
@@ -4551,7 +4551,7 @@
       </p:sp>
       <p:sp>
         <p:nvSpPr>
-          <p:cNvPr id="2059104653" name="Footer Placeholder 5"/>
+          <p:cNvPr id="1945118850" name="Footer Placeholder 5"/>
           <p:cNvSpPr>
             <a:spLocks noGrp="1"/>
           </p:cNvSpPr>
@@ -4573,7 +4573,7 @@
       </p:sp>
       <p:sp>
         <p:nvSpPr>
-          <p:cNvPr id="1628356286" name="Slide Number Placeholder 6"/>
+          <p:cNvPr id="1645399579" name="Slide Number Placeholder 6"/>
           <p:cNvSpPr>
             <a:spLocks noGrp="1"/>
           </p:cNvSpPr>
@@ -4624,7 +4624,7 @@
       </p:grpSpPr>
       <p:sp>
         <p:nvSpPr>
-          <p:cNvPr id="1837271297" name="Title 1"/>
+          <p:cNvPr id="1042738869" name="Title 1"/>
           <p:cNvSpPr>
             <a:spLocks noGrp="1"/>
           </p:cNvSpPr>
@@ -4659,7 +4659,7 @@
       </p:sp>
       <p:sp>
         <p:nvSpPr>
-          <p:cNvPr id="1621062887" name="Picture Placeholder 2"/>
+          <p:cNvPr id="1793666806" name="Picture Placeholder 2"/>
           <p:cNvSpPr>
             <a:spLocks noGrp="1"/>
           </p:cNvSpPr>
@@ -4723,7 +4723,7 @@
       </p:sp>
       <p:sp>
         <p:nvSpPr>
-          <p:cNvPr id="745637186" name="Text Placeholder 3"/>
+          <p:cNvPr id="2033387850" name="Text Placeholder 3"/>
           <p:cNvSpPr>
             <a:spLocks noGrp="1"/>
           </p:cNvSpPr>
@@ -4791,7 +4791,7 @@
       </p:sp>
       <p:sp>
         <p:nvSpPr>
-          <p:cNvPr id="1283983671" name="Date Placeholder 4"/>
+          <p:cNvPr id="1773286853" name="Date Placeholder 4"/>
           <p:cNvSpPr>
             <a:spLocks noGrp="1"/>
           </p:cNvSpPr>
@@ -4817,7 +4817,7 @@
       </p:sp>
       <p:sp>
         <p:nvSpPr>
-          <p:cNvPr id="1494241934" name="Footer Placeholder 5"/>
+          <p:cNvPr id="1436623606" name="Footer Placeholder 5"/>
           <p:cNvSpPr>
             <a:spLocks noGrp="1"/>
           </p:cNvSpPr>
@@ -4839,7 +4839,7 @@
       </p:sp>
       <p:sp>
         <p:nvSpPr>
-          <p:cNvPr id="631558489" name="Slide Number Placeholder 6"/>
+          <p:cNvPr id="1606699590" name="Slide Number Placeholder 6"/>
           <p:cNvSpPr>
             <a:spLocks noGrp="1"/>
           </p:cNvSpPr>
@@ -4895,7 +4895,7 @@
       </p:grpSpPr>
       <p:sp>
         <p:nvSpPr>
-          <p:cNvPr id="835029370" name="Title Placeholder 1"/>
+          <p:cNvPr id="188603298" name="Title Placeholder 1"/>
           <p:cNvSpPr>
             <a:spLocks noGrp="1"/>
           </p:cNvSpPr>
@@ -4931,7 +4931,7 @@
       </p:sp>
       <p:sp>
         <p:nvSpPr>
-          <p:cNvPr id="396852170" name="Text Placeholder 2"/>
+          <p:cNvPr id="1653783276" name="Text Placeholder 2"/>
           <p:cNvSpPr>
             <a:spLocks noGrp="1"/>
           </p:cNvSpPr>
@@ -5007,7 +5007,7 @@
       </p:sp>
       <p:sp>
         <p:nvSpPr>
-          <p:cNvPr id="513591499" name="Date Placeholder 3"/>
+          <p:cNvPr id="1503906209" name="Date Placeholder 3"/>
           <p:cNvSpPr>
             <a:spLocks noGrp="1"/>
           </p:cNvSpPr>
@@ -5051,7 +5051,7 @@
       </p:sp>
       <p:sp>
         <p:nvSpPr>
-          <p:cNvPr id="821895206" name="Footer Placeholder 4"/>
+          <p:cNvPr id="911184360" name="Footer Placeholder 4"/>
           <p:cNvSpPr>
             <a:spLocks noGrp="1"/>
           </p:cNvSpPr>
@@ -5091,7 +5091,7 @@
       </p:sp>
       <p:sp>
         <p:nvSpPr>
-          <p:cNvPr id="1018712552" name="Slide Number Placeholder 5"/>
+          <p:cNvPr id="431392268" name="Slide Number Placeholder 5"/>
           <p:cNvSpPr>
             <a:spLocks noGrp="1"/>
           </p:cNvSpPr>
@@ -5422,7 +5422,7 @@
       </p:grpSpPr>
       <p:sp>
         <p:nvSpPr>
-          <p:cNvPr id="1546107752" name="Title 1"/>
+          <p:cNvPr id="1147464223" name="Title 1"/>
           <p:cNvSpPr>
             <a:spLocks noGrp="1"/>
           </p:cNvSpPr>
@@ -5480,7 +5480,7 @@
       </p:sp>
       <p:pic>
         <p:nvPicPr>
-          <p:cNvPr id="550704565" name="Picture 2" descr="VIT Logo"/>
+          <p:cNvPr id="139960716" name="Picture 2" descr="VIT Logo"/>
           <p:cNvPicPr>
             <a:picLocks noChangeAspect="1" noChangeArrowheads="1"/>
           </p:cNvPicPr>
@@ -5503,14 +5503,14 @@
       </p:pic>
       <p:sp>
         <p:nvSpPr>
-          <p:cNvPr id="265659618" name=""/>
+          <p:cNvPr id="1016778842" name=""/>
           <p:cNvSpPr txBox="1"/>
           <p:nvPr/>
         </p:nvSpPr>
         <p:spPr bwMode="auto">
           <a:xfrm rot="0" flipH="0" flipV="0">
-            <a:off x="3183588" y="2654839"/>
-            <a:ext cx="7073779" cy="4823819"/>
+            <a:off x="2854908" y="2654838"/>
+            <a:ext cx="7091778" cy="4663799"/>
           </a:xfrm>
           <a:prstGeom prst="rect">
             <a:avLst/>
@@ -5529,7 +5529,7 @@
               <a:defRPr/>
             </a:pPr>
             <a:r>
-              <a:rPr lang="en-US" sz="2300">
+              <a:rPr lang="en-IN" sz="2000">
                 <a:solidFill>
                   <a:schemeClr val="accent1">
                     <a:lumMod val="50000"/>
@@ -5539,9 +5539,35 @@
                 <a:ea typeface="Times New Roman"/>
                 <a:cs typeface="Times New Roman"/>
               </a:rPr>
-              <a:t>Project Work Review-1 </a:t>
-            </a:r>
-            <a:endParaRPr sz="2300">
+              <a:t>PASET697 </a:t>
+            </a:r>
+            <a:r>
+              <a:rPr lang="en-US" sz="2000">
+                <a:solidFill>
+                  <a:schemeClr val="accent1">
+                    <a:lumMod val="50000"/>
+                  </a:schemeClr>
+                </a:solidFill>
+                <a:latin typeface="Times New Roman"/>
+                <a:ea typeface="Times New Roman"/>
+                <a:cs typeface="Times New Roman"/>
+              </a:rPr>
+              <a:t>Project Work Review-</a:t>
+            </a:r>
+            <a:r>
+              <a:rPr lang="en-IN" sz="2000">
+                <a:solidFill>
+                  <a:schemeClr val="accent1">
+                    <a:lumMod val="50000"/>
+                  </a:schemeClr>
+                </a:solidFill>
+                <a:latin typeface="Times New Roman"/>
+                <a:ea typeface="Times New Roman"/>
+                <a:cs typeface="Times New Roman"/>
+              </a:rPr>
+              <a:t> II</a:t>
+            </a:r>
+            <a:endParaRPr sz="2000">
               <a:solidFill>
                 <a:schemeClr val="accent1">
                   <a:lumMod val="50000"/>
@@ -5560,7 +5586,7 @@
               <a:defRPr/>
             </a:pPr>
             <a:r>
-              <a:rPr lang="en-US" sz="2300">
+              <a:rPr lang="en-US" sz="2000">
                 <a:solidFill>
                   <a:schemeClr val="accent1">
                     <a:lumMod val="50000"/>
@@ -5572,7 +5598,7 @@
               </a:rPr>
               <a:t>Presented by</a:t>
             </a:r>
-            <a:endParaRPr sz="2300">
+            <a:endParaRPr sz="2000">
               <a:solidFill>
                 <a:schemeClr val="accent1">
                   <a:lumMod val="50000"/>
@@ -5590,7 +5616,7 @@
               <a:defRPr/>
             </a:pPr>
             <a:r>
-              <a:rPr lang="en-US" sz="2300">
+              <a:rPr lang="en-US" sz="2000">
                 <a:solidFill>
                   <a:schemeClr val="accent1">
                     <a:lumMod val="50000"/>
@@ -5602,7 +5628,7 @@
               </a:rPr>
               <a:t>Harsh Pratap Singh (25MCA1027)</a:t>
             </a:r>
-            <a:endParaRPr sz="2300">
+            <a:endParaRPr sz="2000">
               <a:solidFill>
                 <a:schemeClr val="accent1">
                   <a:lumMod val="50000"/>
@@ -5620,7 +5646,38 @@
               </a:lnSpc>
               <a:defRPr/>
             </a:pPr>
-            <a:endParaRPr sz="2300">
+            <a:r>
+              <a:rPr lang="en-IN" sz="2000">
+                <a:solidFill>
+                  <a:schemeClr val="accent1">
+                    <a:lumMod val="50000"/>
+                  </a:schemeClr>
+                </a:solidFill>
+                <a:latin typeface="Times New Roman"/>
+                <a:ea typeface="Times New Roman"/>
+                <a:cs typeface="Times New Roman"/>
+              </a:rPr>
+              <a:t>Masters of Computer Applications</a:t>
+            </a:r>
+            <a:endParaRPr sz="2000">
+              <a:solidFill>
+                <a:schemeClr val="accent1">
+                  <a:lumMod val="50000"/>
+                </a:schemeClr>
+              </a:solidFill>
+              <a:latin typeface="Times New Roman"/>
+              <a:ea typeface="Times New Roman"/>
+              <a:cs typeface="Times New Roman"/>
+            </a:endParaRPr>
+          </a:p>
+          <a:p>
+            <a:pPr algn="ctr">
+              <a:lnSpc>
+                <a:spcPct val="150000"/>
+              </a:lnSpc>
+              <a:defRPr/>
+            </a:pPr>
+            <a:endParaRPr sz="2000">
               <a:solidFill>
                 <a:schemeClr val="accent1">
                   <a:lumMod val="50000"/>
@@ -5638,7 +5695,7 @@
               <a:defRPr/>
             </a:pPr>
             <a:r>
-              <a:rPr lang="en-US" sz="2300" b="0" i="0" u="none" strike="noStrike" cap="none" spc="0">
+              <a:rPr lang="en-US" sz="2000" b="0" i="0" u="none" strike="noStrike" cap="none" spc="0">
                 <a:solidFill>
                   <a:schemeClr val="accent1">
                     <a:lumMod val="50000"/>
@@ -5650,7 +5707,7 @@
               </a:rPr>
               <a:t>Under the Guidance of</a:t>
             </a:r>
-            <a:endParaRPr sz="2300">
+            <a:endParaRPr sz="2000">
               <a:solidFill>
                 <a:schemeClr val="accent1">
                   <a:lumMod val="50000"/>
@@ -5668,7 +5725,7 @@
               <a:defRPr/>
             </a:pPr>
             <a:r>
-              <a:rPr lang="en-US" sz="2300">
+              <a:rPr lang="en-US" sz="2000">
                 <a:solidFill>
                   <a:schemeClr val="accent1">
                     <a:lumMod val="50000"/>
@@ -5680,7 +5737,7 @@
               </a:rPr>
               <a:t>Dr. Saranya G</a:t>
             </a:r>
-            <a:endParaRPr sz="2300">
+            <a:endParaRPr sz="2000">
               <a:solidFill>
                 <a:schemeClr val="accent1">
                   <a:lumMod val="50000"/>
@@ -5698,7 +5755,7 @@
               <a:defRPr/>
             </a:pPr>
             <a:r>
-              <a:rPr lang="en-US" sz="2300">
+              <a:rPr lang="en-US" sz="2000">
                 <a:solidFill>
                   <a:schemeClr val="accent1">
                     <a:lumMod val="50000"/>
@@ -5710,7 +5767,7 @@
               </a:rPr>
               <a:t>Assistant professor-Senior Grade</a:t>
             </a:r>
-            <a:endParaRPr sz="2300">
+            <a:endParaRPr sz="2000">
               <a:solidFill>
                 <a:schemeClr val="accent1">
                   <a:lumMod val="50000"/>
@@ -5728,7 +5785,7 @@
               <a:defRPr/>
             </a:pPr>
             <a:r>
-              <a:rPr lang="en-US" sz="2300" b="0" i="0" u="none" strike="noStrike" cap="none" spc="0">
+              <a:rPr lang="en-US" sz="2000" b="0" i="0" u="none" strike="noStrike" cap="none" spc="0">
                 <a:solidFill>
                   <a:schemeClr val="accent1">
                     <a:lumMod val="50000"/>
@@ -5740,7 +5797,7 @@
               </a:rPr>
               <a:t>School of Computer Science and Engineering</a:t>
             </a:r>
-            <a:endParaRPr sz="2300">
+            <a:endParaRPr sz="2000">
               <a:latin typeface="Times New Roman"/>
               <a:cs typeface="Times New Roman"/>
             </a:endParaRPr>
@@ -5753,7 +5810,7 @@
               <a:defRPr/>
             </a:pPr>
             <a:r>
-              <a:rPr lang="en-US" sz="2300" b="0" i="0" u="none" strike="noStrike" cap="none" spc="0">
+              <a:rPr lang="en-US" sz="2000" b="0" i="0" u="none" strike="noStrike" cap="none" spc="0">
                 <a:solidFill>
                   <a:schemeClr val="accent1">
                     <a:lumMod val="50000"/>
@@ -5766,7 +5823,7 @@
               <a:t>Vellore Institute of Technology, Chennai</a:t>
             </a:r>
             <a:r>
-              <a:rPr lang="en-US" sz="2300" b="0" i="0" u="none" strike="noStrike" cap="none" spc="0">
+              <a:rPr lang="en-US" sz="2000" b="0" i="0" u="none" strike="noStrike" cap="none" spc="0">
                 <a:solidFill>
                   <a:schemeClr val="tx1"/>
                 </a:solidFill>
@@ -5776,7 +5833,7 @@
               </a:rPr>
               <a:t>.</a:t>
             </a:r>
-            <a:endParaRPr sz="2300">
+            <a:endParaRPr sz="2000">
               <a:latin typeface="Times New Roman"/>
               <a:cs typeface="Times New Roman"/>
             </a:endParaRPr>
@@ -5818,7 +5875,7 @@
       </p:grpSpPr>
       <p:sp>
         <p:nvSpPr>
-          <p:cNvPr id="1593261535" name="Title 1"/>
+          <p:cNvPr id="580664861" name="Title 1"/>
           <p:cNvSpPr>
             <a:spLocks noGrp="1"/>
           </p:cNvSpPr>
@@ -5866,7 +5923,7 @@
       </p:sp>
       <p:sp>
         <p:nvSpPr>
-          <p:cNvPr id="1178775519" name="Content Placeholder 2"/>
+          <p:cNvPr id="1615778949" name="Content Placeholder 2"/>
           <p:cNvSpPr>
             <a:spLocks noGrp="1"/>
           </p:cNvSpPr>
@@ -6008,7 +6065,7 @@
       </p:sp>
       <p:sp>
         <p:nvSpPr>
-          <p:cNvPr id="348811067" name="Slide Number Placeholder 3"/>
+          <p:cNvPr id="1389686320" name="Slide Number Placeholder 3"/>
           <p:cNvSpPr>
             <a:spLocks noGrp="1"/>
           </p:cNvSpPr>
@@ -6067,7 +6124,7 @@
       </p:grpSpPr>
       <p:sp>
         <p:nvSpPr>
-          <p:cNvPr id="169525923" name="Title 1"/>
+          <p:cNvPr id="1050454674" name="Title 1"/>
           <p:cNvSpPr>
             <a:spLocks noGrp="1"/>
           </p:cNvSpPr>
@@ -6110,7 +6167,7 @@
       </p:sp>
       <p:sp>
         <p:nvSpPr>
-          <p:cNvPr id="462004350" name="Slide Number Placeholder 3"/>
+          <p:cNvPr id="1669576054" name="Slide Number Placeholder 3"/>
           <p:cNvSpPr>
             <a:spLocks noGrp="1"/>
           </p:cNvSpPr>
@@ -6136,7 +6193,7 @@
       </p:sp>
       <p:pic>
         <p:nvPicPr>
-          <p:cNvPr id="1043822411" name=""/>
+          <p:cNvPr id="1755661433" name=""/>
           <p:cNvPicPr>
             <a:picLocks noChangeAspect="1"/>
           </p:cNvPicPr>
@@ -6191,7 +6248,7 @@
       </p:grpSpPr>
       <p:sp>
         <p:nvSpPr>
-          <p:cNvPr id="1252072830" name="Title 1"/>
+          <p:cNvPr id="431901292" name="Title 1"/>
           <p:cNvSpPr>
             <a:spLocks noGrp="1"/>
           </p:cNvSpPr>
@@ -6234,7 +6291,7 @@
       </p:sp>
       <p:sp>
         <p:nvSpPr>
-          <p:cNvPr id="842853314" name="Content Placeholder 2"/>
+          <p:cNvPr id="1729076522" name="Content Placeholder 2"/>
           <p:cNvSpPr>
             <a:spLocks noGrp="1"/>
           </p:cNvSpPr>
@@ -6527,7 +6584,7 @@
       </p:sp>
       <p:sp>
         <p:nvSpPr>
-          <p:cNvPr id="1871039273" name="Slide Number Placeholder 3"/>
+          <p:cNvPr id="962229062" name="Slide Number Placeholder 3"/>
           <p:cNvSpPr>
             <a:spLocks noGrp="1"/>
           </p:cNvSpPr>
@@ -6586,7 +6643,7 @@
       </p:grpSpPr>
       <p:sp>
         <p:nvSpPr>
-          <p:cNvPr id="256203463" name="Title 1"/>
+          <p:cNvPr id="520141075" name="Title 1"/>
           <p:cNvSpPr>
             <a:spLocks noGrp="1"/>
           </p:cNvSpPr>
@@ -6629,7 +6686,7 @@
       </p:sp>
       <p:sp>
         <p:nvSpPr>
-          <p:cNvPr id="1731640242" name="Content Placeholder 2"/>
+          <p:cNvPr id="1815289813" name="Content Placeholder 2"/>
           <p:cNvSpPr>
             <a:spLocks noGrp="1"/>
           </p:cNvSpPr>
@@ -6729,7 +6786,7 @@
       </p:sp>
       <p:sp>
         <p:nvSpPr>
-          <p:cNvPr id="483518252" name="Slide Number Placeholder 3"/>
+          <p:cNvPr id="1661787345" name="Slide Number Placeholder 3"/>
           <p:cNvSpPr>
             <a:spLocks noGrp="1"/>
           </p:cNvSpPr>
@@ -6788,7 +6845,7 @@
       </p:grpSpPr>
       <p:sp>
         <p:nvSpPr>
-          <p:cNvPr id="1197463864" name="Title 1"/>
+          <p:cNvPr id="1740675027" name="Title 1"/>
           <p:cNvSpPr>
             <a:spLocks noGrp="1"/>
           </p:cNvSpPr>
@@ -6831,7 +6888,7 @@
       </p:sp>
       <p:sp>
         <p:nvSpPr>
-          <p:cNvPr id="797019951" name="Slide Number Placeholder 3"/>
+          <p:cNvPr id="1827624323" name="Slide Number Placeholder 3"/>
           <p:cNvSpPr>
             <a:spLocks noGrp="1"/>
           </p:cNvSpPr>
@@ -6857,7 +6914,7 @@
       </p:sp>
       <p:pic>
         <p:nvPicPr>
-          <p:cNvPr id="989148204" name=""/>
+          <p:cNvPr id="101720667" name=""/>
           <p:cNvPicPr>
             <a:picLocks noChangeAspect="1"/>
           </p:cNvPicPr>
@@ -6880,7 +6937,7 @@
       </p:pic>
       <p:pic>
         <p:nvPicPr>
-          <p:cNvPr id="418896275" name=""/>
+          <p:cNvPr id="1649358707" name=""/>
           <p:cNvPicPr>
             <a:picLocks noChangeAspect="1"/>
           </p:cNvPicPr>
@@ -6903,7 +6960,7 @@
       </p:pic>
       <p:pic>
         <p:nvPicPr>
-          <p:cNvPr id="1802108541" name=""/>
+          <p:cNvPr id="2050781828" name=""/>
           <p:cNvPicPr>
             <a:picLocks noChangeAspect="1"/>
           </p:cNvPicPr>
@@ -6926,7 +6983,7 @@
       </p:pic>
       <p:pic>
         <p:nvPicPr>
-          <p:cNvPr id="1590408338" name=""/>
+          <p:cNvPr id="1308809245" name=""/>
           <p:cNvPicPr>
             <a:picLocks noChangeAspect="1"/>
           </p:cNvPicPr>
@@ -6934,12 +6991,12 @@
         </p:nvPicPr>
         <p:blipFill rotWithShape="1">
           <a:blip r:embed="rId5"/>
-          <a:srcRect l="0" t="64252" r="0" b="0"/>
+          <a:srcRect l="0" t="64251" r="0" b="0"/>
           <a:stretch/>
         </p:blipFill>
         <p:spPr bwMode="auto">
           <a:xfrm flipH="0" flipV="0">
-            <a:off x="10082667" y="1718035"/>
+            <a:off x="10082666" y="1718035"/>
             <a:ext cx="2507426" cy="3680330"/>
           </a:xfrm>
           <a:prstGeom prst="rect">
@@ -6949,7 +7006,7 @@
       </p:pic>
       <p:pic>
         <p:nvPicPr>
-          <p:cNvPr id="36047255" name=""/>
+          <p:cNvPr id="778248995" name=""/>
           <p:cNvPicPr>
             <a:picLocks noChangeAspect="1"/>
           </p:cNvPicPr>
@@ -6962,7 +7019,7 @@
         </p:blipFill>
         <p:spPr bwMode="auto">
           <a:xfrm flipH="0" flipV="0">
-            <a:off x="4916179" y="1718035"/>
+            <a:off x="4916178" y="1718035"/>
             <a:ext cx="2435164" cy="3821864"/>
           </a:xfrm>
           <a:prstGeom prst="rect">
@@ -7005,7 +7062,7 @@
       </p:grpSpPr>
       <p:sp>
         <p:nvSpPr>
-          <p:cNvPr id="1109287388" name="Title 1"/>
+          <p:cNvPr id="1246169974" name="Title 1"/>
           <p:cNvSpPr>
             <a:spLocks noGrp="1"/>
           </p:cNvSpPr>
@@ -7027,7 +7084,7 @@
       </p:sp>
       <p:sp>
         <p:nvSpPr>
-          <p:cNvPr id="1064026399" name="Slide Number Placeholder 5"/>
+          <p:cNvPr id="1603014356" name="Slide Number Placeholder 5"/>
           <p:cNvSpPr>
             <a:spLocks noGrp="1"/>
           </p:cNvSpPr>
@@ -7053,7 +7110,7 @@
       </p:sp>
       <p:sp>
         <p:nvSpPr>
-          <p:cNvPr id="2042428133" name="Title 1"/>
+          <p:cNvPr id="81683395" name="Title 1"/>
           <p:cNvSpPr>
             <a:spLocks noGrp="1"/>
           </p:cNvSpPr>
@@ -7130,7 +7187,7 @@
       </p:sp>
       <p:pic>
         <p:nvPicPr>
-          <p:cNvPr id="835713011" name=""/>
+          <p:cNvPr id="1645667291" name=""/>
           <p:cNvPicPr>
             <a:picLocks noChangeAspect="1"/>
           </p:cNvPicPr>
@@ -7153,7 +7210,7 @@
       </p:pic>
       <p:pic>
         <p:nvPicPr>
-          <p:cNvPr id="1601068407" name=""/>
+          <p:cNvPr id="1302179154" name=""/>
           <p:cNvPicPr>
             <a:picLocks noChangeAspect="1"/>
           </p:cNvPicPr>
@@ -7176,7 +7233,7 @@
       </p:pic>
       <p:pic>
         <p:nvPicPr>
-          <p:cNvPr id="1114503552" name=""/>
+          <p:cNvPr id="2060307480" name=""/>
           <p:cNvPicPr>
             <a:picLocks noChangeAspect="1"/>
           </p:cNvPicPr>
@@ -7199,7 +7256,7 @@
       </p:pic>
       <p:pic>
         <p:nvPicPr>
-          <p:cNvPr id="1359688353" name=""/>
+          <p:cNvPr id="336788908" name=""/>
           <p:cNvPicPr>
             <a:picLocks noChangeAspect="1"/>
           </p:cNvPicPr>
@@ -7255,7 +7312,7 @@
       </p:grpSpPr>
       <p:sp>
         <p:nvSpPr>
-          <p:cNvPr id="1492989349" name="Title 1"/>
+          <p:cNvPr id="1701199461" name="Title 1"/>
           <p:cNvSpPr>
             <a:spLocks noGrp="1"/>
           </p:cNvSpPr>
@@ -7298,7 +7355,7 @@
       </p:sp>
       <p:sp>
         <p:nvSpPr>
-          <p:cNvPr id="2124804764" name="Content Placeholder 2"/>
+          <p:cNvPr id="1991641760" name="Content Placeholder 2"/>
           <p:cNvSpPr>
             <a:spLocks noGrp="1"/>
           </p:cNvSpPr>
@@ -7409,7 +7466,7 @@
       </p:sp>
       <p:sp>
         <p:nvSpPr>
-          <p:cNvPr id="426740083" name="Slide Number Placeholder 3"/>
+          <p:cNvPr id="238375281" name="Slide Number Placeholder 3"/>
           <p:cNvSpPr>
             <a:spLocks noGrp="1"/>
           </p:cNvSpPr>
@@ -7468,7 +7525,7 @@
       </p:grpSpPr>
       <p:sp>
         <p:nvSpPr>
-          <p:cNvPr id="544769577" name="Title 1"/>
+          <p:cNvPr id="1378589311" name="Title 1"/>
           <p:cNvSpPr>
             <a:spLocks noGrp="1"/>
           </p:cNvSpPr>
@@ -7511,7 +7568,7 @@
       </p:sp>
       <p:sp>
         <p:nvSpPr>
-          <p:cNvPr id="465781782" name="Slide Number Placeholder 3"/>
+          <p:cNvPr id="1508700323" name="Slide Number Placeholder 3"/>
           <p:cNvSpPr>
             <a:spLocks noGrp="1"/>
           </p:cNvSpPr>
@@ -7537,7 +7594,7 @@
       </p:sp>
       <p:sp>
         <p:nvSpPr>
-          <p:cNvPr id="1564539902" name="TextBox 2"/>
+          <p:cNvPr id="1423417635" name="TextBox 2"/>
           <p:cNvSpPr txBox="1"/>
           <p:nvPr/>
         </p:nvSpPr>
@@ -7566,7 +7623,7 @@
       </p:sp>
       <p:pic>
         <p:nvPicPr>
-          <p:cNvPr id="1247439817" name=""/>
+          <p:cNvPr id="98891917" name=""/>
           <p:cNvPicPr>
             <a:picLocks noChangeAspect="1"/>
           </p:cNvPicPr>
@@ -7621,7 +7678,7 @@
       </p:grpSpPr>
       <p:sp>
         <p:nvSpPr>
-          <p:cNvPr id="895121900" name="Title 1"/>
+          <p:cNvPr id="1299765051" name="Title 1"/>
           <p:cNvSpPr>
             <a:spLocks noGrp="1"/>
           </p:cNvSpPr>
@@ -7689,7 +7746,7 @@
       </p:sp>
       <p:sp>
         <p:nvSpPr>
-          <p:cNvPr id="1056180531" name="TextBox 15"/>
+          <p:cNvPr id="1995649261" name="TextBox 15"/>
           <p:cNvSpPr txBox="1"/>
           <p:nvPr/>
         </p:nvSpPr>
@@ -8143,7 +8200,7 @@
       </p:grpSpPr>
       <p:sp>
         <p:nvSpPr>
-          <p:cNvPr id="1316934299" name="Title 1"/>
+          <p:cNvPr id="1153025575" name="Title 1"/>
           <p:cNvSpPr>
             <a:spLocks noGrp="1"/>
           </p:cNvSpPr>
@@ -8188,7 +8245,7 @@
       </p:sp>
       <p:sp>
         <p:nvSpPr>
-          <p:cNvPr id="754999294" name="Content Placeholder 2"/>
+          <p:cNvPr id="593702881" name="Content Placeholder 2"/>
           <p:cNvSpPr>
             <a:spLocks noGrp="1"/>
           </p:cNvSpPr>
@@ -8547,7 +8604,7 @@
       </p:sp>
       <p:sp>
         <p:nvSpPr>
-          <p:cNvPr id="460547044" name="Slide Number Placeholder 3"/>
+          <p:cNvPr id="428409595" name="Slide Number Placeholder 3"/>
           <p:cNvSpPr>
             <a:spLocks noGrp="1"/>
           </p:cNvSpPr>
@@ -8606,7 +8663,7 @@
       </p:grpSpPr>
       <p:sp>
         <p:nvSpPr>
-          <p:cNvPr id="842058959" name="Slide Number Placeholder 3"/>
+          <p:cNvPr id="1283112100" name="Slide Number Placeholder 3"/>
           <p:cNvSpPr>
             <a:spLocks noGrp="1"/>
           </p:cNvSpPr>
@@ -8632,7 +8689,7 @@
       </p:sp>
       <p:sp>
         <p:nvSpPr>
-          <p:cNvPr id="509438519" name="Title 1"/>
+          <p:cNvPr id="308644926" name="Title 1"/>
           <p:cNvSpPr>
             <a:spLocks noGrp="1"/>
           </p:cNvSpPr>
@@ -8678,7 +8735,7 @@
       </p:sp>
       <p:sp>
         <p:nvSpPr>
-          <p:cNvPr id="40165041" name="Content Placeholder 2"/>
+          <p:cNvPr id="1202950148" name="Content Placeholder 2"/>
           <p:cNvSpPr txBox="1"/>
           <p:nvPr/>
         </p:nvSpPr>
@@ -9103,7 +9160,7 @@
       </p:grpSpPr>
       <p:sp>
         <p:nvSpPr>
-          <p:cNvPr id="460328405" name="Title 1"/>
+          <p:cNvPr id="1698120412" name="Title 1"/>
           <p:cNvSpPr>
             <a:spLocks noGrp="1"/>
           </p:cNvSpPr>
@@ -9145,7 +9202,7 @@
       </p:sp>
       <p:sp>
         <p:nvSpPr>
-          <p:cNvPr id="1370610569" name="Slide Number Placeholder 2"/>
+          <p:cNvPr id="498345797" name="Slide Number Placeholder 2"/>
           <p:cNvSpPr>
             <a:spLocks noGrp="1"/>
           </p:cNvSpPr>
@@ -9204,7 +9261,7 @@
       </p:grpSpPr>
       <p:sp>
         <p:nvSpPr>
-          <p:cNvPr id="57352368" name="Title 1"/>
+          <p:cNvPr id="1757524978" name="Title 1"/>
           <p:cNvSpPr>
             <a:spLocks noGrp="1"/>
           </p:cNvSpPr>
@@ -9252,7 +9309,7 @@
       </p:sp>
       <p:sp>
         <p:nvSpPr>
-          <p:cNvPr id="1791959078" name="Content Placeholder 2"/>
+          <p:cNvPr id="184853520" name="Content Placeholder 2"/>
           <p:cNvSpPr>
             <a:spLocks noGrp="1"/>
           </p:cNvSpPr>
@@ -9465,7 +9522,7 @@
       </p:sp>
       <p:sp>
         <p:nvSpPr>
-          <p:cNvPr id="1399900928" name="Slide Number Placeholder 3"/>
+          <p:cNvPr id="960723073" name="Slide Number Placeholder 3"/>
           <p:cNvSpPr>
             <a:spLocks noGrp="1"/>
           </p:cNvSpPr>
@@ -9524,7 +9581,7 @@
       </p:grpSpPr>
       <p:sp>
         <p:nvSpPr>
-          <p:cNvPr id="714027958" name="Title 1"/>
+          <p:cNvPr id="223825177" name="Title 1"/>
           <p:cNvSpPr>
             <a:spLocks noGrp="1"/>
           </p:cNvSpPr>
@@ -9572,7 +9629,7 @@
       </p:sp>
       <p:sp>
         <p:nvSpPr>
-          <p:cNvPr id="580627178" name="Content Placeholder 2"/>
+          <p:cNvPr id="462818463" name="Content Placeholder 2"/>
           <p:cNvSpPr>
             <a:spLocks noGrp="1"/>
           </p:cNvSpPr>
@@ -9714,7 +9771,7 @@
       </p:sp>
       <p:sp>
         <p:nvSpPr>
-          <p:cNvPr id="1369786651" name="Slide Number Placeholder 3"/>
+          <p:cNvPr id="607727425" name="Slide Number Placeholder 3"/>
           <p:cNvSpPr>
             <a:spLocks noGrp="1"/>
           </p:cNvSpPr>
@@ -9773,7 +9830,7 @@
       </p:grpSpPr>
       <p:sp>
         <p:nvSpPr>
-          <p:cNvPr id="1437223249" name="Title 1"/>
+          <p:cNvPr id="881975847" name="Title 1"/>
           <p:cNvSpPr>
             <a:spLocks noGrp="1"/>
           </p:cNvSpPr>
@@ -9821,7 +9878,7 @@
       </p:sp>
       <p:sp>
         <p:nvSpPr>
-          <p:cNvPr id="1157356678" name="Slide Number Placeholder 3"/>
+          <p:cNvPr id="1330751363" name="Slide Number Placeholder 3"/>
           <p:cNvSpPr>
             <a:spLocks noGrp="1"/>
           </p:cNvSpPr>
@@ -9847,7 +9904,7 @@
       </p:sp>
       <p:graphicFrame>
         <p:nvGraphicFramePr>
-          <p:cNvPr id="1784181361" name="Content Placeholder 5"/>
+          <p:cNvPr id="1519053332" name="Content Placeholder 5"/>
           <p:cNvGraphicFramePr>
             <a:graphicFrameLocks xmlns:a="http://schemas.openxmlformats.org/drawingml/2006/main"/>
           </p:cNvGraphicFramePr>
@@ -10298,7 +10355,29 @@
                           <a:ea typeface="Times New Roman"/>
                           <a:cs typeface="Times New Roman"/>
                         </a:rPr>
-                        <a:t>It does not use NLP to analyze the context or themes of a user's day, which is a key part of your project's novelty.</a:t>
+                        <a:t>It does not use NLP to analyze the context or themes of a user's day, which is a key part of </a:t>
+                      </a:r>
+                      <a:r>
+                        <a:rPr lang="en-IN" sz="1300" b="0" i="0" u="none">
+                          <a:solidFill>
+                            <a:srgbClr val="000000"/>
+                          </a:solidFill>
+                          <a:latin typeface="Times New Roman"/>
+                          <a:ea typeface="Times New Roman"/>
+                          <a:cs typeface="Times New Roman"/>
+                        </a:rPr>
+                        <a:t>my </a:t>
+                      </a:r>
+                      <a:r>
+                        <a:rPr sz="1300" b="0" i="0" u="none">
+                          <a:solidFill>
+                            <a:srgbClr val="000000"/>
+                          </a:solidFill>
+                          <a:latin typeface="Times New Roman"/>
+                          <a:ea typeface="Times New Roman"/>
+                          <a:cs typeface="Times New Roman"/>
+                        </a:rPr>
+                        <a:t>project's novelty.</a:t>
                       </a:r>
                       <a:endParaRPr sz="1300">
                         <a:latin typeface="Times New Roman"/>
@@ -10708,7 +10787,29 @@
                           <a:ea typeface="Times New Roman"/>
                           <a:cs typeface="Times New Roman"/>
                         </a:rPr>
-                        <a:t>Proposes a specific, advanced method for finding personalized effects, which is exactly what your project aims to do. </a:t>
+                        <a:t>Proposes a specific, advanced method for finding personalized effects, which is exactly what </a:t>
+                      </a:r>
+                      <a:r>
+                        <a:rPr lang="en-IN" sz="1300" b="0" i="0" u="none">
+                          <a:solidFill>
+                            <a:srgbClr val="000000"/>
+                          </a:solidFill>
+                          <a:latin typeface="Times New Roman"/>
+                          <a:ea typeface="Times New Roman"/>
+                          <a:cs typeface="Times New Roman"/>
+                        </a:rPr>
+                        <a:t>my </a:t>
+                      </a:r>
+                      <a:r>
+                        <a:rPr sz="1300" b="0" i="0" u="none">
+                          <a:solidFill>
+                            <a:srgbClr val="000000"/>
+                          </a:solidFill>
+                          <a:latin typeface="Times New Roman"/>
+                          <a:ea typeface="Times New Roman"/>
+                          <a:cs typeface="Times New Roman"/>
+                        </a:rPr>
+                        <a:t>project aims to do. </a:t>
                       </a:r>
                       <a:endParaRPr sz="1300">
                         <a:latin typeface="Times New Roman"/>
@@ -10747,7 +10848,18 @@
                           <a:ea typeface="Times New Roman"/>
                           <a:cs typeface="Times New Roman"/>
                         </a:rPr>
-                        <a:t>Highly statistical and complex. </a:t>
+                        <a:t>Highly statistical and complex</a:t>
+                      </a:r>
+                      <a:r>
+                        <a:rPr lang="en-IN" sz="1300" b="0" i="0" u="none">
+                          <a:solidFill>
+                            <a:srgbClr val="000000"/>
+                          </a:solidFill>
+                          <a:latin typeface="Times New Roman"/>
+                          <a:ea typeface="Times New Roman"/>
+                          <a:cs typeface="Times New Roman"/>
+                        </a:rPr>
+                        <a:t>,</a:t>
                       </a:r>
                       <a:r>
                         <a:rPr sz="1300" b="0" i="0" u="none">
@@ -10758,7 +10870,18 @@
                           <a:ea typeface="Times New Roman"/>
                           <a:cs typeface="Times New Roman"/>
                         </a:rPr>
-                        <a:t>A full implementation may be beyond the scope of one project, but it proves the need for "n-of-1" models. </a:t>
+                        <a:t> </a:t>
+                      </a:r>
+                      <a:r>
+                        <a:rPr sz="1300" b="0" i="0" u="none">
+                          <a:solidFill>
+                            <a:srgbClr val="000000"/>
+                          </a:solidFill>
+                          <a:latin typeface="Times New Roman"/>
+                          <a:ea typeface="Times New Roman"/>
+                          <a:cs typeface="Times New Roman"/>
+                        </a:rPr>
+                        <a:t> but it proves the need for "n-of-1" models. </a:t>
                       </a:r>
                       <a:endParaRPr sz="1300">
                         <a:latin typeface="Times New Roman"/>
@@ -11052,7 +11175,7 @@
       </p:grpSpPr>
       <p:sp>
         <p:nvSpPr>
-          <p:cNvPr id="2111564891" name="Title 1"/>
+          <p:cNvPr id="1860811304" name="Title 1"/>
           <p:cNvSpPr>
             <a:spLocks noGrp="1"/>
           </p:cNvSpPr>
@@ -11100,7 +11223,7 @@
       </p:sp>
       <p:sp>
         <p:nvSpPr>
-          <p:cNvPr id="528246688" name="Slide Number Placeholder 4"/>
+          <p:cNvPr id="20894754" name="Slide Number Placeholder 4"/>
           <p:cNvSpPr>
             <a:spLocks noGrp="1"/>
           </p:cNvSpPr>
@@ -11126,7 +11249,7 @@
       </p:sp>
       <p:graphicFrame>
         <p:nvGraphicFramePr>
-          <p:cNvPr id="582364130" name="Content Placeholder 5"/>
+          <p:cNvPr id="1577299695" name="Content Placeholder 5"/>
           <p:cNvGraphicFramePr>
             <a:graphicFrameLocks xmlns:a="http://schemas.openxmlformats.org/drawingml/2006/main"/>
           </p:cNvGraphicFramePr>
@@ -12316,7 +12439,7 @@
       </p:grpSpPr>
       <p:sp>
         <p:nvSpPr>
-          <p:cNvPr id="2036209394" name="Title 1"/>
+          <p:cNvPr id="603528639" name="Title 1"/>
           <p:cNvSpPr>
             <a:spLocks noGrp="1"/>
           </p:cNvSpPr>
@@ -12370,7 +12493,7 @@
       </p:sp>
       <p:sp>
         <p:nvSpPr>
-          <p:cNvPr id="169228300" name="Slide Number Placeholder 3"/>
+          <p:cNvPr id="2097863174" name="Slide Number Placeholder 3"/>
           <p:cNvSpPr>
             <a:spLocks noGrp="1"/>
           </p:cNvSpPr>
@@ -12396,7 +12519,7 @@
       </p:sp>
       <p:graphicFrame>
         <p:nvGraphicFramePr>
-          <p:cNvPr id="1639521799" name="Content Placeholder 5"/>
+          <p:cNvPr id="246054235" name="Content Placeholder 5"/>
           <p:cNvGraphicFramePr>
             <a:graphicFrameLocks xmlns:a="http://schemas.openxmlformats.org/drawingml/2006/main"/>
           </p:cNvGraphicFramePr>
@@ -13108,7 +13231,7 @@
       </p:grpSpPr>
       <p:sp>
         <p:nvSpPr>
-          <p:cNvPr id="1041417116" name="Title 1"/>
+          <p:cNvPr id="659360000" name="Title 1"/>
           <p:cNvSpPr>
             <a:spLocks noGrp="1"/>
           </p:cNvSpPr>
@@ -13162,7 +13285,7 @@
       </p:sp>
       <p:sp>
         <p:nvSpPr>
-          <p:cNvPr id="2105331735" name="Slide Number Placeholder 3"/>
+          <p:cNvPr id="1232206995" name="Slide Number Placeholder 3"/>
           <p:cNvSpPr>
             <a:spLocks noGrp="1"/>
           </p:cNvSpPr>
@@ -13188,7 +13311,7 @@
       </p:sp>
       <p:sp>
         <p:nvSpPr>
-          <p:cNvPr id="600086714" name=""/>
+          <p:cNvPr id="1946363057" name=""/>
           <p:cNvSpPr/>
           <p:nvPr/>
         </p:nvSpPr>
@@ -13375,7 +13498,7 @@
       </p:grpSpPr>
       <p:sp>
         <p:nvSpPr>
-          <p:cNvPr id="1459592886" name="Title 1"/>
+          <p:cNvPr id="1837506812" name="Title 1"/>
           <p:cNvSpPr>
             <a:spLocks noGrp="1"/>
           </p:cNvSpPr>
@@ -13423,7 +13546,7 @@
       </p:sp>
       <p:sp>
         <p:nvSpPr>
-          <p:cNvPr id="5284059" name="Slide Number Placeholder 3"/>
+          <p:cNvPr id="1230700148" name="Slide Number Placeholder 3"/>
           <p:cNvSpPr>
             <a:spLocks noGrp="1"/>
           </p:cNvSpPr>
@@ -13449,7 +13572,7 @@
       </p:sp>
       <p:sp>
         <p:nvSpPr>
-          <p:cNvPr id="2106990806" name=""/>
+          <p:cNvPr id="1770691382" name=""/>
           <p:cNvSpPr/>
           <p:nvPr/>
         </p:nvSpPr>

</xml_diff>